<commit_message>
Fix remaining PbP.BDB 2018-playoffs mischaracterization in Grad Module 3
The slide deck and three text files (Coding_Exercise script, Practice
Questions, References) still described PbP.BDB as 2017-18 NBA playoff
data after the rest of the module's text files were corrected. PbP.BDB
is Golden State's real, complete 2017-18 regular-season play-by-play
log (82 games); Boston's data is limited to the two real regular-season
games the two teams played against each other that season. Rewrote all
11 affected slides (text surgery on the slide XML, QA'd with
validate.py, markitdown+grep, and a visual thumbnail review) and the
three text files to match the already-corrected narrative.
</commit_message>
<xml_diff>
--- a/Sports-Analytics-Graduate/03_Clutch_Performance_and_Situational_Splits/Lecture_Slides/Module03_Clutch_Performance_and_Situational_Splits.pptx
+++ b/Sports-Analytics-Graduate/03_Clutch_Performance_and_Situational_Splits/Lecture_Slides/Module03_Clutch_Performance_and_Situational_Splits.pptx
@@ -6489,7 +6489,7 @@
                 <a:ea typeface="Calibri" pitchFamily="34" charset="-122"/>
                 <a:cs typeface="Calibri" pitchFamily="34" charset="-120"/>
               </a:rPr>
-              <a:t>fourfactors(Tboxes, Oboxes), Team=Clutch/General. Data: PbP.BDB, 2017-18 NBA playoffs.</a:t>
+              <a:t>fourfactors(Tboxes, Oboxes), Team=Clutch/General. Data: PbP.BDB, Golden State's real full 2017-18 regular season.</a:t>
             </a:r>
             <a:endParaRPr lang="en-US" sz="1000" dirty="0"/>
           </a:p>
@@ -7009,7 +7009,7 @@
                 <a:ea typeface="Calibri" pitchFamily="34" charset="-122"/>
                 <a:cs typeface="Calibri" pitchFamily="34" charset="-120"/>
               </a:rPr>
-              <a:t>fourfactors(Tboxes, Oboxes), Team=Clutch/General. Data: PbP.BDB, 2017-18 NBA playoffs.</a:t>
+              <a:t>fourfactors(Tboxes, Oboxes), Team=Clutch/General. Data: PbP.BDB, Boston's two real 2017-18 regular-season games vs. Golden State.</a:t>
             </a:r>
             <a:endParaRPr lang="en-US" sz="1000" dirty="0"/>
           </a:p>
@@ -7242,7 +7242,7 @@
                 <a:ea typeface="Calibri" pitchFamily="34" charset="-122"/>
                 <a:cs typeface="Calibri" pitchFamily="34" charset="-120"/>
               </a:rPr>
-              <a:t>General to Clutch, 2018 playoffs</a:t>
+              <a:t>General to Clutch, 2017-18 regular season</a:t>
             </a:r>
             <a:endParaRPr lang="en-US" sz="1300" dirty="0"/>
           </a:p>
@@ -8182,7 +8182,7 @@
                 <a:ea typeface="Calibri" pitchFamily="34" charset="-122"/>
                 <a:cs typeface="Calibri" pitchFamily="34" charset="-120"/>
               </a:rPr>
-              <a:t>The precise clutch definition, the TOPboxes() pipeline, and real Clutch-vs-General Four Factors splits for two 2018 playoff teams moving in two different real directions.</a:t>
+              <a:t>The precise clutch definition, the TOPboxes() pipeline, and real Clutch-vs-General Four Factors splits for Golden State's full real season and Boston's real two-game sample against them, moving in two different real directions.</a:t>
             </a:r>
             <a:endParaRPr lang="en-US" sz="1400" dirty="0"/>
           </a:p>
@@ -9101,7 +9101,7 @@
                 <a:ea typeface="Calibri" pitchFamily="34" charset="-122"/>
                 <a:cs typeface="Calibri" pitchFamily="34" charset="-120"/>
               </a:rPr>
-              <a:t>inequality(Pbox$PTS, nplayers). Data: PbP.BDB, 2017-18 NBA playoffs.</a:t>
+              <a:t>inequality(Pbox$PTS, nplayers). Data: PbP.BDB, Golden State's real full 2017-18 regular season.</a:t>
             </a:r>
             <a:endParaRPr lang="en-US" sz="1000" dirty="0"/>
           </a:p>
@@ -9274,7 +9274,7 @@
                 <a:ea typeface="Calibri" pitchFamily="34" charset="-122"/>
                 <a:cs typeface="Calibri" pitchFamily="34" charset="-120"/>
               </a:rPr>
-              <a:t>inequality(Pbox$PTS, nplayers). Data: PbP.BDB, 2017-18 NBA playoffs.</a:t>
+              <a:t>inequality(Pbox$PTS, nplayers). Data: PbP.BDB, Boston's two real 2017-18 regular-season games vs. Golden State.</a:t>
             </a:r>
             <a:endParaRPr lang="en-US" sz="1000" dirty="0"/>
           </a:p>
@@ -10261,7 +10261,7 @@
                 <a:ea typeface="Calibri" pitchFamily="34" charset="-122"/>
                 <a:cs typeface="Calibri" pitchFamily="34" charset="-120"/>
               </a:rPr>
-              <a:t>Real footage from the same 2018 postseason this module's data comes from. Watch for which three players the offense actually runs through in the closing minutes.</a:t>
+              <a:t>Real footage from the same Golden State roster this module's real regular-season data comes from, during the year they went on to win the 2018 title. Watch for which three players the offense actually runs through in the closing minutes.</a:t>
             </a:r>
             <a:endParaRPr lang="en-US" sz="1300" dirty="0"/>
           </a:p>
@@ -11783,7 +11783,7 @@
                 <a:ea typeface="Calibri" pitchFamily="34" charset="-122"/>
                 <a:cs typeface="Calibri" pitchFamily="34" charset="-120"/>
               </a:rPr>
-              <a:t>bubbleplot(): x=SPc, y=Diff, color=Prc, size=MINcp. Data: PbP.BDB, 2017-18 NBA playoffs.</a:t>
+              <a:t>bubbleplot(): x=SPc, y=Diff, color=Prc, size=MINcp. Data: PbP.BDB, Golden State's real full 2017-18 regular season.</a:t>
             </a:r>
             <a:endParaRPr lang="en-US" sz="1000" dirty="0"/>
           </a:p>
@@ -13796,7 +13796,7 @@
                 <a:ea typeface="Calibri" pitchFamily="34" charset="-122"/>
                 <a:cs typeface="Calibri" pitchFamily="34" charset="-120"/>
               </a:rPr>
-              <a:t>Only two Boston players cleared this module's minimum clutch-attempt threshold -- a real, honest consequence of using a smaller, playoffs-only sample (see the methodological note from Segment 1).</a:t>
+              <a:t>Only two Boston players cleared this module's minimum clutch-attempt threshold -- a real, honest consequence of using a much smaller, two-game real sample against Golden State (see the methodological note from Segment 1).</a:t>
             </a:r>
             <a:endParaRPr lang="en-US" sz="1450" dirty="0"/>
           </a:p>
@@ -16155,7 +16155,7 @@
                 <a:ea typeface="Calibri" pitchFamily="34" charset="-122"/>
                 <a:cs typeface="Calibri" pitchFamily="34" charset="-120"/>
               </a:rPr>
-              <a:t>Team-level clutch shifts are real but team-specific -- Golden State's defense worsened while Boston's offense improved, in the same real postseason.</a:t>
+              <a:t>Team-level clutch shifts are real but team-specific -- Golden State's defense worsened while Boston's offense improved, across the same real 2017-18 season.</a:t>
             </a:r>
             <a:endParaRPr lang="en-US" sz="1500" dirty="0"/>
           </a:p>
@@ -16279,7 +16279,7 @@
                 <a:ea typeface="Calibri" pitchFamily="34" charset="-122"/>
                 <a:cs typeface="Calibri" pitchFamily="34" charset="-120"/>
               </a:rPr>
-              <a:t>Every number in this module came from PbP.BDB, real 2017-18 NBA playoff play-by-play data, reproducible by running Coding_Exercise/module3_clutch_splits.R.</a:t>
+              <a:t>Every number in this module came from PbP.BDB, Golden State's real, complete 2017-18 NBA regular-season play-by-play log, reproducible by running Coding_Exercise/module3_clutch_splits.R.</a:t>
             </a:r>
             <a:endParaRPr lang="en-US" sz="1500" dirty="0"/>
           </a:p>
@@ -18449,7 +18449,7 @@
                 <a:ea typeface="Calibri" pitchFamily="34" charset="-122"/>
                 <a:cs typeface="Calibri" pitchFamily="34" charset="-120"/>
               </a:rPr>
-              <a:t>The textbook builds its Chapter 3 example from a private play-by-play file covering the Celtics' and Warriors' 2021-22 regular season and playoffs. That specific file is not part of the public BasketballAnalyzeR package. This module reproduces the identical PbPmanipulation/TOPboxes/fourfactors/inequality pipeline, and the same clutch indices, on real, freely available data instead: PbP.BDB, the entire real 2017-18 NBA playoffs, still using the Celtics and Warriors as our two case-study teams.</a:t>
+              <a:t>The textbook builds its Chapter 3 example from a private play-by-play file covering the Celtics' and Warriors' 2021-22 regular season and playoffs. That specific file is not part of the public BasketballAnalyzeR package. This module reproduces the identical PbPmanipulation/TOPboxes/fourfactors/inequality pipeline, and the same clutch indices, on real, freely available data instead: PbP.BDB, Golden State's real, complete 2017-18 NBA regular-season play-by-play log (82 games), still using Golden State and, in their two real regular-season meetings that year, the Boston Celtics as our two case-study teams.</a:t>
             </a:r>
             <a:endParaRPr lang="en-US" sz="1550" dirty="0"/>
           </a:p>

</xml_diff>